<commit_message>
C2: documenta diario P02 e integra l’analisi con C1
</commit_message>
<xml_diff>
--- a/C2/presentazione/bozza/CIBY-C2-bozza.pptx
+++ b/C2/presentazione/bozza/CIBY-C2-bozza.pptx
@@ -2,38 +2,38 @@
 <file path=ppt/presentation.xml><?xml version="1.0" encoding="utf-8"?>
 <p:presentation xmlns:p="http://schemas.openxmlformats.org/presentationml/2006/main">
   <p:sldMasterIdLst>
-    <p:sldMasterId xmlns:r="http://schemas.openxmlformats.org/officeDocument/2006/relationships" id="2147483648" r:id="R6ee58b127315471f"/>
+    <p:sldMasterId xmlns:r="http://schemas.openxmlformats.org/officeDocument/2006/relationships" id="2147483648" r:id="R63d71f61290a4f85"/>
   </p:sldMasterIdLst>
   <p:notesMasterIdLst>
-    <p:notesMasterId xmlns:r="http://schemas.openxmlformats.org/officeDocument/2006/relationships" r:id="R6308aee0acd642a0"/>
+    <p:notesMasterId xmlns:r="http://schemas.openxmlformats.org/officeDocument/2006/relationships" r:id="R99a0e3f478cf4391"/>
   </p:notesMasterIdLst>
   <p:sldIdLst>
-    <p:sldId xmlns:r="http://schemas.openxmlformats.org/officeDocument/2006/relationships" id="256" r:id="R260e4a17d17c4db2"/>
-    <p:sldId xmlns:r="http://schemas.openxmlformats.org/officeDocument/2006/relationships" id="257" r:id="R1752a9cc44014cd9"/>
-    <p:sldId xmlns:r="http://schemas.openxmlformats.org/officeDocument/2006/relationships" id="258" r:id="R9b44897db197403d"/>
-    <p:sldId xmlns:r="http://schemas.openxmlformats.org/officeDocument/2006/relationships" id="259" r:id="R28613055461248d5"/>
-    <p:sldId xmlns:r="http://schemas.openxmlformats.org/officeDocument/2006/relationships" id="260" r:id="R19b2963fe204465d"/>
-    <p:sldId xmlns:r="http://schemas.openxmlformats.org/officeDocument/2006/relationships" id="261" r:id="R7d1fc2f76ca64c24"/>
-    <p:sldId xmlns:r="http://schemas.openxmlformats.org/officeDocument/2006/relationships" id="262" r:id="R733b6f4f49054f4a"/>
-    <p:sldId xmlns:r="http://schemas.openxmlformats.org/officeDocument/2006/relationships" id="263" r:id="Ree01b094ccc84da8"/>
-    <p:sldId xmlns:r="http://schemas.openxmlformats.org/officeDocument/2006/relationships" id="264" r:id="Rec643f3741984f67"/>
-    <p:sldId xmlns:r="http://schemas.openxmlformats.org/officeDocument/2006/relationships" id="265" r:id="R02a77dec2d014d9d"/>
-    <p:sldId xmlns:r="http://schemas.openxmlformats.org/officeDocument/2006/relationships" id="266" r:id="R987e57864c0a4193"/>
-    <p:sldId xmlns:r="http://schemas.openxmlformats.org/officeDocument/2006/relationships" id="267" r:id="R9c00e19682d34c16"/>
-    <p:sldId xmlns:r="http://schemas.openxmlformats.org/officeDocument/2006/relationships" id="268" r:id="R8d71883477994069"/>
-    <p:sldId xmlns:r="http://schemas.openxmlformats.org/officeDocument/2006/relationships" id="269" r:id="Rcad8c8d9a6034d24"/>
-    <p:sldId xmlns:r="http://schemas.openxmlformats.org/officeDocument/2006/relationships" id="270" r:id="Rd21fb78e1ff94e8d"/>
-    <p:sldId xmlns:r="http://schemas.openxmlformats.org/officeDocument/2006/relationships" id="271" r:id="R321849f8ae874c77"/>
-    <p:sldId xmlns:r="http://schemas.openxmlformats.org/officeDocument/2006/relationships" id="272" r:id="Rabafdd1ef3914b70"/>
-    <p:sldId xmlns:r="http://schemas.openxmlformats.org/officeDocument/2006/relationships" id="273" r:id="R7ab9cd22d6fa47c3"/>
-    <p:sldId xmlns:r="http://schemas.openxmlformats.org/officeDocument/2006/relationships" id="274" r:id="Rdca9b67502784e54"/>
-    <p:sldId xmlns:r="http://schemas.openxmlformats.org/officeDocument/2006/relationships" id="275" r:id="R5897e4fb7eb24cf6"/>
-    <p:sldId xmlns:r="http://schemas.openxmlformats.org/officeDocument/2006/relationships" id="276" r:id="Rccfcbfa8b0b4462d"/>
-    <p:sldId xmlns:r="http://schemas.openxmlformats.org/officeDocument/2006/relationships" id="277" r:id="Rfbffee9d39e54f7c"/>
-    <p:sldId xmlns:r="http://schemas.openxmlformats.org/officeDocument/2006/relationships" id="278" r:id="R60244ad9f67c48d1"/>
-    <p:sldId xmlns:r="http://schemas.openxmlformats.org/officeDocument/2006/relationships" id="279" r:id="Rf3aabe92b8ef4af2"/>
-    <p:sldId xmlns:r="http://schemas.openxmlformats.org/officeDocument/2006/relationships" id="280" r:id="R0e1910bf8c1740a8"/>
-    <p:sldId xmlns:r="http://schemas.openxmlformats.org/officeDocument/2006/relationships" id="281" r:id="R25829516e8e545e7"/>
+    <p:sldId xmlns:r="http://schemas.openxmlformats.org/officeDocument/2006/relationships" id="256" r:id="R15bff159764e41ac"/>
+    <p:sldId xmlns:r="http://schemas.openxmlformats.org/officeDocument/2006/relationships" id="257" r:id="Rbcbe30a1d752452e"/>
+    <p:sldId xmlns:r="http://schemas.openxmlformats.org/officeDocument/2006/relationships" id="258" r:id="Rc9a4fefbdd55424b"/>
+    <p:sldId xmlns:r="http://schemas.openxmlformats.org/officeDocument/2006/relationships" id="259" r:id="Rc4ac5404e6dc4a8a"/>
+    <p:sldId xmlns:r="http://schemas.openxmlformats.org/officeDocument/2006/relationships" id="260" r:id="R0a406834557a4965"/>
+    <p:sldId xmlns:r="http://schemas.openxmlformats.org/officeDocument/2006/relationships" id="261" r:id="R562ed214ab6d4304"/>
+    <p:sldId xmlns:r="http://schemas.openxmlformats.org/officeDocument/2006/relationships" id="262" r:id="Raed29bdf79ef4d8b"/>
+    <p:sldId xmlns:r="http://schemas.openxmlformats.org/officeDocument/2006/relationships" id="263" r:id="R52971885518d44f5"/>
+    <p:sldId xmlns:r="http://schemas.openxmlformats.org/officeDocument/2006/relationships" id="264" r:id="Rf8c4a8ac28f443bb"/>
+    <p:sldId xmlns:r="http://schemas.openxmlformats.org/officeDocument/2006/relationships" id="265" r:id="Rfde19e6871324bc9"/>
+    <p:sldId xmlns:r="http://schemas.openxmlformats.org/officeDocument/2006/relationships" id="266" r:id="Rbd3e1eabcc9443c8"/>
+    <p:sldId xmlns:r="http://schemas.openxmlformats.org/officeDocument/2006/relationships" id="267" r:id="Rb76f088c293b4c31"/>
+    <p:sldId xmlns:r="http://schemas.openxmlformats.org/officeDocument/2006/relationships" id="268" r:id="R3b70325b7670413e"/>
+    <p:sldId xmlns:r="http://schemas.openxmlformats.org/officeDocument/2006/relationships" id="269" r:id="R8812149120634511"/>
+    <p:sldId xmlns:r="http://schemas.openxmlformats.org/officeDocument/2006/relationships" id="270" r:id="R9ad89267b025485f"/>
+    <p:sldId xmlns:r="http://schemas.openxmlformats.org/officeDocument/2006/relationships" id="271" r:id="R913ca32190774bb4"/>
+    <p:sldId xmlns:r="http://schemas.openxmlformats.org/officeDocument/2006/relationships" id="272" r:id="R415e04f3d5ac4af1"/>
+    <p:sldId xmlns:r="http://schemas.openxmlformats.org/officeDocument/2006/relationships" id="273" r:id="Rb488834472ec4eb2"/>
+    <p:sldId xmlns:r="http://schemas.openxmlformats.org/officeDocument/2006/relationships" id="274" r:id="Rbf176bebbbf745a9"/>
+    <p:sldId xmlns:r="http://schemas.openxmlformats.org/officeDocument/2006/relationships" id="275" r:id="Rb0c448577b4649a5"/>
+    <p:sldId xmlns:r="http://schemas.openxmlformats.org/officeDocument/2006/relationships" id="276" r:id="Rb1690d1961854d1a"/>
+    <p:sldId xmlns:r="http://schemas.openxmlformats.org/officeDocument/2006/relationships" id="277" r:id="R65bcf1084d0743e7"/>
+    <p:sldId xmlns:r="http://schemas.openxmlformats.org/officeDocument/2006/relationships" id="278" r:id="R342db71e7e904393"/>
+    <p:sldId xmlns:r="http://schemas.openxmlformats.org/officeDocument/2006/relationships" id="279" r:id="R510431a70cf94d3f"/>
+    <p:sldId xmlns:r="http://schemas.openxmlformats.org/officeDocument/2006/relationships" id="280" r:id="R0f7e09b91a624d77"/>
+    <p:sldId xmlns:r="http://schemas.openxmlformats.org/officeDocument/2006/relationships" id="281" r:id="R93a37151fe324ff9"/>
   </p:sldIdLst>
   <p:sldSz cx="12192000" cy="6858000"/>
   <p:notesSz cx="6858000" cy="9144000"/>
@@ -575,6 +575,16 @@
               <a:t>https://github.com/andremauroo/CIBY/blob/main/C1/report%20interviste/P05.pdf</a:t>
             </a:r>
           </a:p>
+          <a:p xmlns:a="http://schemas.openxmlformats.org/drawingml/2006/main">
+            <a:br/>
+            <a:r>
+              <a:t>https://github.com/andremauroo/CIBY/blob/main/C2/report/analisi-tematica.md</a:t>
+            </a:r>
+            <a:br/>
+            <a:r>
+              <a:t>Il nuovo diario sostiene un rinvio riuscito per B03. Le quantità di B04 restano fondate sulle interviste C1. Non si attribuisce alla panna di P03 un’eliminazione accertata.</a:t>
+            </a:r>
+          </a:p>
         </p:txBody>
       </p:sp>
       <p:sp>
@@ -668,6 +678,16 @@
           <a:p xmlns:a="http://schemas.openxmlformats.org/drawingml/2006/main">
             <a:r>
               <a:t>https://github.com/andremauroo/CIBY/blob/main/C1/report%20interviste/P05.pdf</a:t>
+            </a:r>
+          </a:p>
+          <a:p xmlns:a="http://schemas.openxmlformats.org/drawingml/2006/main">
+            <a:br/>
+            <a:r>
+              <a:t>https://github.com/andremauroo/CIBY/blob/main/C2/preparazione/personas-e-scenari.md</a:t>
+            </a:r>
+            <a:br/>
+            <a:r>
+              <a:t>Il riesame del diario non introduce un nuovo archetipo. Luca rimane persona primaria di lavoro; il rinvio riuscito non giustifica un profilo incapace di adattarsi. Il diario non documenta un ingrediente mancante, quantità eccessive o dimenticanze.</a:t>
             </a:r>
           </a:p>
         </p:txBody>
@@ -910,6 +930,16 @@
               <a:t>Scenario concettuale: dettagli, supporto ed esito sono costruzioni progettuali, non episodi osservati.</a:t>
             </a:r>
           </a:p>
+          <a:p xmlns:a="http://schemas.openxmlformats.org/drawingml/2006/main">
+            <a:br/>
+            <a:r>
+              <a:t>https://github.com/andremauroo/CIBY/blob/main/C2/report/analisi-tematica.md</a:t>
+            </a:r>
+            <a:br/>
+            <a:r>
+              <a:t>Il diario P02 aggiunge un rinvio riuscito senza causa annotata. Il dettaglio dell’ingrediente mancante rimane fondato sulla C1 e appartiene allo scenario concettuale; non viene attribuito al diario.</a:t>
+            </a:r>
+          </a:p>
         </p:txBody>
       </p:sp>
       <p:sp>
@@ -1074,6 +1104,16 @@
             <a:br/>
             <a:r>
               <a:t>Ulteriori contributi individuali di Gabriele, Rime ed Edoardo riletti nella board il 26 ottobre. Sintesi e collegamenti agli originali in C2/preparazione/brainstorming-e-scelta.md. Mancano ancora le idee di Emanuele e la documentazione della selezione conclusiva. Le immagini mostrano gli esempi iniziali di Andrea e Marco.</a:t>
+            </a:r>
+          </a:p>
+          <a:p xmlns:a="http://schemas.openxmlformats.org/drawingml/2006/main">
+            <a:br/>
+            <a:r>
+              <a:t>https://github.com/andremauroo/CIBY/blob/main/C2/preparazione/brainstorming-e-scelta.md</a:t>
+            </a:r>
+            <a:br/>
+            <a:r>
+              <a:t>Presenti anche le tre idee di Emanuele: 188:389, 188:393, 188:397 nella board. Le immagini mostrano esempi iniziali di Andrea e Marco; le immagini conclusive saranno aggiornate con la selezione.</a:t>
             </a:r>
           </a:p>
         </p:txBody>
@@ -1329,6 +1369,20 @@
           <a:p xmlns:a="http://schemas.openxmlformats.org/drawingml/2006/main">
             <a:r>
               <a:t>Compito2-focus.pdf, pp. 1-2, riferimento operativo del corso. Consegna C2 del 26 ottobre 2026.</a:t>
+            </a:r>
+          </a:p>
+          <a:p xmlns:a="http://schemas.openxmlformats.org/drawingml/2006/main">
+            <a:br/>
+            <a:r>
+              <a:t>https://github.com/andremauroo/CIBY/blob/main/C2/report/analisi-tematica.md</a:t>
+            </a:r>
+            <a:br/>
+            <a:r>
+              <a:t>https://github.com/andremauroo/CIBY/blob/main/C2/report/confronto-gruppo.md</a:t>
+            </a:r>
+            <a:br/>
+            <a:r>
+              <a:t>La nuova raccolta orienta la progettazione ma non seleziona da sola D3. Metodo ed esito effettivo del confronto del gruppo restano da documentare.</a:t>
             </a:r>
           </a:p>
         </p:txBody>
@@ -1667,6 +1721,20 @@
               <a:t>https://www.figma.com/board/Aa9cVd9wI6ifqZyzO30I9m/Compito-2</a:t>
             </a:r>
           </a:p>
+          <a:p xmlns:a="http://schemas.openxmlformats.org/drawingml/2006/main">
+            <a:br/>
+            <a:r>
+              <a:t>https://github.com/andremauroo/CIBY/blob/main/C2/report/P02-diario-originale.md</a:t>
+            </a:r>
+            <a:br/>
+            <a:r>
+              <a:t>https://github.com/andremauroo/CIBY/blob/main/C2/report/P02-diario.md</a:t>
+            </a:r>
+            <a:br/>
+            <a:r>
+              <a:t>https://github.com/andremauroo/CIBY/blob/main/C2/report/analisi-tematica.md</a:t>
+            </a:r>
+          </a:p>
         </p:txBody>
       </p:sp>
       <p:sp>
@@ -1740,6 +1808,16 @@
           <a:p xmlns:a="http://schemas.openxmlformats.org/drawingml/2006/main">
             <a:r>
               <a:t>Archetipo sintetico sui temi C1. Nome, età e dettagli narrativi non identificano singoli partecipanti.</a:t>
+            </a:r>
+          </a:p>
+          <a:p xmlns:a="http://schemas.openxmlformats.org/drawingml/2006/main">
+            <a:br/>
+            <a:r>
+              <a:t>https://github.com/andremauroo/CIBY/blob/main/C2/preparazione/personas-e-scenari.md</a:t>
+            </a:r>
+            <a:br/>
+            <a:r>
+              <a:t>P02-D01-E05/E07 e C01 aggiungono un rinvio riuscito. La persona resta un archetipo e le frustrazioni non sono nuovi eventi del diario.</a:t>
             </a:r>
           </a:p>
         </p:txBody>
@@ -2172,6 +2250,20 @@
               <a:t>Aggiornamento del 26 ottobre: diario non ancora ricevuto.</a:t>
             </a:r>
           </a:p>
+          <a:p xmlns:a="http://schemas.openxmlformats.org/drawingml/2006/main">
+            <a:br/>
+            <a:r>
+              <a:t>https://github.com/andremauroo/CIBY/blob/main/C2/report/P02-diario.md</a:t>
+            </a:r>
+            <a:br/>
+            <a:r>
+              <a:t>https://github.com/andremauroo/CIBY/blob/main/C2/report/P02-diario-originale.md</a:t>
+            </a:r>
+            <a:br/>
+            <a:r>
+              <a:t>Periodo 21–26 ottobre 2026, sei giorni. Appunti compilati giorno per giorno sul telefono, ricevuti il 26 ottobre. Dodici voci: undici di pranzo/cena (una prevista e rinviata) e una di dopocena. La spesa quotidiana è informazione di contesto M02, non un registro dei prodotti acquistati. Mensa universitaria esplicita il 26; altri luoghi non annotati. P02 è lo stesso partecipante C1, non una nuova intervista.</a:t>
+            </a:r>
+          </a:p>
         </p:txBody>
       </p:sp>
       <p:sp>
@@ -2247,6 +2339,20 @@
               <a:t>https://github.com/andremauroo/CIBY/blob/main/C2/preparazione/requisiti-e-piano.md</a:t>
             </a:r>
           </a:p>
+          <a:p xmlns:a="http://schemas.openxmlformats.org/drawingml/2006/main">
+            <a:br/>
+            <a:r>
+              <a:t>https://github.com/andremauroo/CIBY/blob/main/C2/report/P02-diario-originale.md</a:t>
+            </a:r>
+            <a:br/>
+            <a:r>
+              <a:t>https://github.com/andremauroo/CIBY/blob/main/C2/report/P02-diario.md</a:t>
+            </a:r>
+            <a:br/>
+            <a:r>
+              <a:t>E05 è un’intenzione per venerdì, E07 il consumo sabato; C01 chiarisce la sequenza. Il testo originale non è stato corretto retroattivamente. Non sono due consumi della stessa bowl; non si assumono avanzi già cotti, stesso lotto, quantità, causa sociale o allenamento.</a:t>
+            </a:r>
+          </a:p>
         </p:txBody>
       </p:sp>
       <p:sp>
@@ -2320,6 +2426,20 @@
           <a:p xmlns:a="http://schemas.openxmlformats.org/drawingml/2006/main">
             <a:r>
               <a:t>Compito2-focus.pdf, pp. 1-2, riferimento operativo del corso. Consegna C2 del 26 ottobre 2026.</a:t>
+            </a:r>
+          </a:p>
+          <a:p xmlns:a="http://schemas.openxmlformats.org/drawingml/2006/main">
+            <a:br/>
+            <a:r>
+              <a:t>https://github.com/andremauroo/CIBY/blob/main/C2/report/analisi-tematica.md</a:t>
+            </a:r>
+            <a:br/>
+            <a:r>
+              <a:t>https://github.com/andremauroo/CIBY/blob/main/C2/report/P02-diario.md</a:t>
+            </a:r>
+            <a:br/>
+            <a:r>
+              <a:t>C1: P02-E02/E05/E07/E08 e C01; P03-E04; P01-E03/E09. C2: P02-D01-E03/E04/E05/E07/E10, M02 e C01. B03 approfondito come attività, senza dimostrazione del bisogno di un’app; B02/C07 contestualizzati. B01 e B04 non ricevono nuove prove dirette. Gli ingredienti ricorrenti non provano avanzi o stesso lotto.</a:t>
             </a:r>
           </a:p>
         </p:txBody>
@@ -5012,12 +5132,12 @@
   </p:cSld>
   <p:clrMap bg1="lt1" tx1="dk1" bg2="lt2" tx2="dk2" accent1="accent1" accent2="accent2" accent3="accent3" accent4="accent4" accent5="accent5" accent6="accent6" hlink="hlink" folHlink="folHlink"/>
   <p:sldLayoutIdLst>
-    <p:sldLayoutId xmlns:r="http://schemas.openxmlformats.org/officeDocument/2006/relationships" id="2147483649" r:id="R3623602fe89648bb"/>
-    <p:sldLayoutId xmlns:r="http://schemas.openxmlformats.org/officeDocument/2006/relationships" id="2147483650" r:id="Ree2a254368bc4038"/>
-    <p:sldLayoutId xmlns:r="http://schemas.openxmlformats.org/officeDocument/2006/relationships" id="2147483651" r:id="Rea0f3a1c81094feb"/>
-    <p:sldLayoutId xmlns:r="http://schemas.openxmlformats.org/officeDocument/2006/relationships" id="2147483652" r:id="R576fa38295ff4eac"/>
-    <p:sldLayoutId xmlns:r="http://schemas.openxmlformats.org/officeDocument/2006/relationships" id="2147483653" r:id="R233deda0b3dd4a22"/>
-    <p:sldLayoutId xmlns:r="http://schemas.openxmlformats.org/officeDocument/2006/relationships" id="2147483654" r:id="Rdb9ed0d68ca94e3e"/>
+    <p:sldLayoutId xmlns:r="http://schemas.openxmlformats.org/officeDocument/2006/relationships" id="2147483649" r:id="Ra08c332bd1e8477f"/>
+    <p:sldLayoutId xmlns:r="http://schemas.openxmlformats.org/officeDocument/2006/relationships" id="2147483650" r:id="R29f8a5591bfa4d99"/>
+    <p:sldLayoutId xmlns:r="http://schemas.openxmlformats.org/officeDocument/2006/relationships" id="2147483651" r:id="R1876832b8dbc4aaa"/>
+    <p:sldLayoutId xmlns:r="http://schemas.openxmlformats.org/officeDocument/2006/relationships" id="2147483652" r:id="Rc5ba8e3e5f12470f"/>
+    <p:sldLayoutId xmlns:r="http://schemas.openxmlformats.org/officeDocument/2006/relationships" id="2147483653" r:id="R264dd55a1e4b4e52"/>
+    <p:sldLayoutId xmlns:r="http://schemas.openxmlformats.org/officeDocument/2006/relationships" id="2147483654" r:id="R760fb161aff941d1"/>
   </p:sldLayoutIdLst>
   <p:txStyles>
     <p:titleStyle>
@@ -6930,7 +7050,7 @@
                 <a:ea typeface="Noto Sans"/>
                 <a:cs typeface="Noto Sans"/>
               </a:rPr>
-              <a:t>P02-E06/E07/E08 e C01; P03-E04/E05/E07/E08 · Bozza C2</a:t>
+              <a:t>C1: P02/P03; C2: P02-D01-E05/E07, C01 · Bozza C2</a:t>
             </a:r>
           </a:p>
         </p:txBody>
@@ -7455,7 +7575,7 @@
           <a:bodyPr xmlns:a="http://schemas.openxmlformats.org/drawingml/2006/main" anchor="t"/>
           <a:lstStyle xmlns:a="http://schemas.openxmlformats.org/drawingml/2006/main">
             <a:defPPr>
-              <a:defRPr sz="1875" b="0">
+              <a:defRPr sz="1800" b="0">
                 <a:solidFill>
                   <a:srgbClr val="263B34"/>
                 </a:solidFill>
@@ -7574,7 +7694,7 @@
               </a:defRPr>
             </a:pPr>
             <a:r>
-              <a:rPr sz="1875" b="0">
+              <a:rPr sz="1800" b="0">
                 <a:solidFill>
                   <a:srgbClr val="263B34"/>
                 </a:solidFill>
@@ -7582,7 +7702,7 @@
                 <a:ea typeface="Noto Sans"/>
                 <a:cs typeface="Noto Sans"/>
               </a:rPr>
-              <a:t>P02-E07/E08: confezioni avanzate e programmi cambiati.</a:t>
+              <a:t>C1: P02-E07/E08, programmi cambiati; P03-E04, rinvio del pollo riuscito; P03-E08, panna inutilizzata.</a:t>
             </a:r>
           </a:p>
           <a:p xmlns:a="http://schemas.openxmlformats.org/drawingml/2006/main">
@@ -7595,7 +7715,7 @@
               </a:defRPr>
             </a:pPr>
             <a:r>
-              <a:rPr sz="1875" b="0">
+              <a:rPr sz="1800" b="0">
                 <a:solidFill>
                   <a:srgbClr val="263B34"/>
                 </a:solidFill>
@@ -7603,7 +7723,7 @@
                 <a:ea typeface="Noto Sans"/>
                 <a:cs typeface="Noto Sans"/>
               </a:rPr>
-              <a:t>P03-E04: rinvio del pollo riuscito. P03-E08: panna inutilizzata per un ingrediente mancante, senza eliminazione accertata.</a:t>
+              <a:t>C2: bowl prevista venerdì, consumata sabato (P02-D01-E05/E07, C01).</a:t>
             </a:r>
           </a:p>
         </p:txBody>
@@ -7965,7 +8085,7 @@
           <a:bodyPr xmlns:a="http://schemas.openxmlformats.org/drawingml/2006/main" anchor="t"/>
           <a:lstStyle xmlns:a="http://schemas.openxmlformats.org/drawingml/2006/main">
             <a:defPPr>
-              <a:defRPr sz="1950" b="0">
+              <a:defRPr sz="1800" b="0">
                 <a:solidFill>
                   <a:srgbClr val="263B34"/>
                 </a:solidFill>
@@ -8084,7 +8204,7 @@
               </a:defRPr>
             </a:pPr>
             <a:r>
-              <a:rPr sz="1950" b="0">
+              <a:rPr sz="1800" b="0">
                 <a:solidFill>
                   <a:srgbClr val="263B34"/>
                 </a:solidFill>
@@ -8092,7 +8212,7 @@
                 <a:ea typeface="Noto Sans"/>
                 <a:cs typeface="Noto Sans"/>
               </a:rPr>
-              <a:t>P02-E06/E07: quantità minime e confezioni grandi.</a:t>
+              <a:t>C1: P02-E06/E07, confezioni grandi; P03-E05/E07, quantità e occasioni.</a:t>
             </a:r>
           </a:p>
           <a:p xmlns:a="http://schemas.openxmlformats.org/drawingml/2006/main">
@@ -8105,7 +8225,7 @@
               </a:defRPr>
             </a:pPr>
             <a:r>
-              <a:rPr sz="1950" b="0">
+              <a:rPr sz="1800" b="0">
                 <a:solidFill>
                   <a:srgbClr val="263B34"/>
                 </a:solidFill>
@@ -8113,7 +8233,7 @@
                 <a:ea typeface="Noto Sans"/>
                 <a:cs typeface="Noto Sans"/>
               </a:rPr>
-              <a:t>P03-E05/E07: tempi di consumo dei freschi e confezioni che superano l’uso previsto.</a:t>
+              <a:t>Il diario C2 non riporta quantità o confezioni.</a:t>
             </a:r>
           </a:p>
         </p:txBody>
@@ -8631,7 +8751,7 @@
                 <a:ea typeface="Noto Sans"/>
                 <a:cs typeface="Noto Sans"/>
               </a:rPr>
-              <a:t>Archetipi progettuali fondati sui temi C1, con nomi e dettagli narrativi</a:t>
+              <a:t>Archetipi fondati sulla C1, riesaminati con il diario P02</a:t>
             </a:r>
           </a:p>
         </p:txBody>
@@ -8794,7 +8914,7 @@
                 <a:ea typeface="Noto Sans"/>
                 <a:cs typeface="Noto Sans"/>
               </a:rPr>
-              <a:t>Personas: sintesi dei temi C1. Schede complete in appendice · Bozza C2</a:t>
+              <a:t>Profili C1 e riesame P02-D01. Schede in appendice · Bozza C2</a:t>
             </a:r>
           </a:p>
         </p:txBody>
@@ -16848,7 +16968,7 @@
           <p:cNvPr id="6" name="">
             <a:extLst xmlns:a="http://schemas.openxmlformats.org/drawingml/2006/main">
               <a:ext uri="{FF2B5EF4-FFF2-40B4-BE49-F238E27FC236}">
-                <a16:creationId xmlns:a16="http://schemas.microsoft.com/office/drawing/2014/main" id="{79B0CC66-D06A-4FAD-AEAD-65E3B79B7F93}"/>
+                <a16:creationId xmlns:a16="http://schemas.microsoft.com/office/drawing/2014/main" id="{384F8978-16C6-47E9-AD88-63118B3D2D17}"/>
               </a:ext>
             </a:extLst>
           </p:cNvPr>
@@ -16858,7 +16978,7 @@
           <p:nvPr/>
         </p:nvPicPr>
         <p:blipFill>
-          <a:blip xmlns:r="http://schemas.openxmlformats.org/officeDocument/2006/relationships" xmlns:a="http://schemas.openxmlformats.org/drawingml/2006/main" r:embed="R3645406033eb42d9"/>
+          <a:blip xmlns:r="http://schemas.openxmlformats.org/officeDocument/2006/relationships" xmlns:a="http://schemas.openxmlformats.org/drawingml/2006/main" r:embed="R26c358c53dfd45e9"/>
           <a:stretch xmlns:a="http://schemas.openxmlformats.org/drawingml/2006/main"/>
         </p:blipFill>
         <p:spPr>
@@ -16876,7 +16996,7 @@
           <p:cNvPr id="7" name="">
             <a:extLst xmlns:a="http://schemas.openxmlformats.org/drawingml/2006/main">
               <a:ext uri="{FF2B5EF4-FFF2-40B4-BE49-F238E27FC236}">
-                <a16:creationId xmlns:a16="http://schemas.microsoft.com/office/drawing/2014/main" id="{F2E39F8C-D988-4736-A435-2DD79CB19709}"/>
+                <a16:creationId xmlns:a16="http://schemas.microsoft.com/office/drawing/2014/main" id="{13B0626A-68C2-4717-95AB-FF5BE9E491D0}"/>
               </a:ext>
             </a:extLst>
           </p:cNvPr>
@@ -16886,7 +17006,7 @@
           <p:nvPr/>
         </p:nvPicPr>
         <p:blipFill>
-          <a:blip xmlns:r="http://schemas.openxmlformats.org/officeDocument/2006/relationships" xmlns:a="http://schemas.openxmlformats.org/drawingml/2006/main" r:embed="Rf43b40f027c6410f"/>
+          <a:blip xmlns:r="http://schemas.openxmlformats.org/officeDocument/2006/relationships" xmlns:a="http://schemas.openxmlformats.org/drawingml/2006/main" r:embed="R5c2394fa17ef435d"/>
           <a:stretch xmlns:a="http://schemas.openxmlformats.org/drawingml/2006/main"/>
         </p:blipFill>
         <p:spPr>
@@ -17060,7 +17180,7 @@
                 <a:ea typeface="Noto Sans"/>
                 <a:cs typeface="Noto Sans"/>
               </a:rPr>
-              <a:t>Già presenti anche Gabriele, Rime ed Edoardo. Restano Emanuele e la selezione.</a:t>
+              <a:t>Presenti le idee di tutti i sei componenti. Scelta conclusiva da documentare.</a:t>
             </a:r>
           </a:p>
         </p:txBody>
@@ -17917,7 +18037,7 @@
           <p:cNvPr id="6" name="">
             <a:extLst xmlns:a="http://schemas.openxmlformats.org/drawingml/2006/main">
               <a:ext uri="{FF2B5EF4-FFF2-40B4-BE49-F238E27FC236}">
-                <a16:creationId xmlns:a16="http://schemas.microsoft.com/office/drawing/2014/main" id="{7311DC72-EC16-4340-B1CD-F6BB6FC0A1A7}"/>
+                <a16:creationId xmlns:a16="http://schemas.microsoft.com/office/drawing/2014/main" id="{3FEA404F-D93F-429F-A06F-9E8082A2836F}"/>
               </a:ext>
             </a:extLst>
           </p:cNvPr>
@@ -19236,7 +19356,7 @@
           <p:cNvPr id="6" name="">
             <a:extLst xmlns:a="http://schemas.openxmlformats.org/drawingml/2006/main">
               <a:ext uri="{FF2B5EF4-FFF2-40B4-BE49-F238E27FC236}">
-                <a16:creationId xmlns:a16="http://schemas.microsoft.com/office/drawing/2014/main" id="{7313CA55-D80F-4868-909D-F056BF2A1700}"/>
+                <a16:creationId xmlns:a16="http://schemas.microsoft.com/office/drawing/2014/main" id="{635EB751-9374-4BCD-9828-82114F92CB16}"/>
               </a:ext>
             </a:extLst>
           </p:cNvPr>
@@ -20768,7 +20888,7 @@
           <a:bodyPr xmlns:a="http://schemas.openxmlformats.org/drawingml/2006/main" anchor="t"/>
           <a:lstStyle xmlns:a="http://schemas.openxmlformats.org/drawingml/2006/main">
             <a:defPPr>
-              <a:defRPr sz="2325" b="0">
+              <a:defRPr sz="2025" b="0">
                 <a:solidFill>
                   <a:srgbClr val="263B34"/>
                 </a:solidFill>
@@ -20887,7 +21007,7 @@
               </a:defRPr>
             </a:pPr>
             <a:r>
-              <a:rPr sz="2325" b="0">
+              <a:rPr sz="2025" b="0">
                 <a:solidFill>
                   <a:srgbClr val="263B34"/>
                 </a:solidFill>
@@ -20895,7 +21015,7 @@
                 <a:ea typeface="Noto Sans"/>
                 <a:cs typeface="Noto Sans"/>
               </a:rPr>
-              <a:t>D3 rende esplicito il legame tra imprevisti, destinazione degli ingredienti e quantità ancora necessarie.</a:t>
+              <a:t>Il diario aggiunge un rinvio riuscito. D3 esplora come confrontare adattamento e rinvio sui prossimi pasti, rispettando le strategie già efficaci.</a:t>
             </a:r>
           </a:p>
         </p:txBody>
@@ -21921,7 +22041,7 @@
           <p:cNvPr id="5" name="">
             <a:extLst xmlns:a="http://schemas.openxmlformats.org/drawingml/2006/main">
               <a:ext uri="{FF2B5EF4-FFF2-40B4-BE49-F238E27FC236}">
-                <a16:creationId xmlns:a16="http://schemas.microsoft.com/office/drawing/2014/main" id="{063642D2-4527-4A23-A36D-8FAB816084D1}"/>
+                <a16:creationId xmlns:a16="http://schemas.microsoft.com/office/drawing/2014/main" id="{64354E3E-2501-495D-A23A-411A6DA4B15F}"/>
               </a:ext>
             </a:extLst>
           </p:cNvPr>
@@ -21931,7 +22051,7 @@
           <p:nvPr/>
         </p:nvPicPr>
         <p:blipFill>
-          <a:blip xmlns:r="http://schemas.openxmlformats.org/officeDocument/2006/relationships" xmlns:a="http://schemas.openxmlformats.org/drawingml/2006/main" r:embed="Rb7a0d53d90524527"/>
+          <a:blip xmlns:r="http://schemas.openxmlformats.org/officeDocument/2006/relationships" xmlns:a="http://schemas.openxmlformats.org/drawingml/2006/main" r:embed="R12f9cf4e84234ce8"/>
           <a:srcRect xmlns:a="http://schemas.openxmlformats.org/drawingml/2006/main" l="23500" t="26333" r="59735" b="53667"/>
           <a:stretch xmlns:a="http://schemas.openxmlformats.org/drawingml/2006/main"/>
         </p:blipFill>
@@ -22116,7 +22236,7 @@
           <p:cNvPr id="7" name="">
             <a:extLst xmlns:a="http://schemas.openxmlformats.org/drawingml/2006/main">
               <a:ext uri="{FF2B5EF4-FFF2-40B4-BE49-F238E27FC236}">
-                <a16:creationId xmlns:a16="http://schemas.microsoft.com/office/drawing/2014/main" id="{AC62812F-CAA5-4A67-866E-35A98D2D13C3}"/>
+                <a16:creationId xmlns:a16="http://schemas.microsoft.com/office/drawing/2014/main" id="{4180BA76-FD5F-40E9-A8AC-351798910702}"/>
               </a:ext>
             </a:extLst>
           </p:cNvPr>
@@ -22126,7 +22246,7 @@
           <p:nvPr/>
         </p:nvPicPr>
         <p:blipFill>
-          <a:blip xmlns:r="http://schemas.openxmlformats.org/officeDocument/2006/relationships" xmlns:a="http://schemas.openxmlformats.org/drawingml/2006/main" r:embed="Rbd9849fe54c24a47"/>
+          <a:blip xmlns:r="http://schemas.openxmlformats.org/officeDocument/2006/relationships" xmlns:a="http://schemas.openxmlformats.org/drawingml/2006/main" r:embed="R372ff877600e4f85"/>
           <a:srcRect xmlns:a="http://schemas.openxmlformats.org/drawingml/2006/main" l="20000" t="4500" r="20000" b="61000"/>
           <a:stretch xmlns:a="http://schemas.openxmlformats.org/drawingml/2006/main"/>
         </p:blipFill>
@@ -22311,7 +22431,7 @@
           <p:cNvPr id="9" name="">
             <a:extLst xmlns:a="http://schemas.openxmlformats.org/drawingml/2006/main">
               <a:ext uri="{FF2B5EF4-FFF2-40B4-BE49-F238E27FC236}">
-                <a16:creationId xmlns:a16="http://schemas.microsoft.com/office/drawing/2014/main" id="{BFBBC79E-21FC-439E-969A-6A146C61F683}"/>
+                <a16:creationId xmlns:a16="http://schemas.microsoft.com/office/drawing/2014/main" id="{8310CF11-26AF-4AF6-BCDF-4E70E5A3211A}"/>
               </a:ext>
             </a:extLst>
           </p:cNvPr>
@@ -22321,7 +22441,7 @@
           <p:nvPr/>
         </p:nvPicPr>
         <p:blipFill>
-          <a:blip xmlns:r="http://schemas.openxmlformats.org/officeDocument/2006/relationships" xmlns:a="http://schemas.openxmlformats.org/drawingml/2006/main" r:embed="R1ee2252854da40e6"/>
+          <a:blip xmlns:r="http://schemas.openxmlformats.org/officeDocument/2006/relationships" xmlns:a="http://schemas.openxmlformats.org/drawingml/2006/main" r:embed="Rb1bf980e31504e4e"/>
           <a:srcRect xmlns:a="http://schemas.openxmlformats.org/drawingml/2006/main" l="0" t="18000" r="0" b="14000"/>
           <a:stretch xmlns:a="http://schemas.openxmlformats.org/drawingml/2006/main"/>
         </p:blipFill>
@@ -22506,7 +22626,7 @@
           <p:cNvPr id="11" name="">
             <a:extLst xmlns:a="http://schemas.openxmlformats.org/drawingml/2006/main">
               <a:ext uri="{FF2B5EF4-FFF2-40B4-BE49-F238E27FC236}">
-                <a16:creationId xmlns:a16="http://schemas.microsoft.com/office/drawing/2014/main" id="{4D418C46-887B-4357-943D-1EB40F9E45D9}"/>
+                <a16:creationId xmlns:a16="http://schemas.microsoft.com/office/drawing/2014/main" id="{1C79ED85-251F-45C1-A5C3-CD7F0ADD20F2}"/>
               </a:ext>
             </a:extLst>
           </p:cNvPr>
@@ -22516,7 +22636,7 @@
           <p:nvPr/>
         </p:nvPicPr>
         <p:blipFill>
-          <a:blip xmlns:r="http://schemas.openxmlformats.org/officeDocument/2006/relationships" xmlns:a="http://schemas.openxmlformats.org/drawingml/2006/main" r:embed="Rdb0be71c1eaa415e"/>
+          <a:blip xmlns:r="http://schemas.openxmlformats.org/officeDocument/2006/relationships" xmlns:a="http://schemas.openxmlformats.org/drawingml/2006/main" r:embed="R4ed12c6062ba4fb4"/>
           <a:srcRect xmlns:a="http://schemas.openxmlformats.org/drawingml/2006/main" l="0" t="0" r="0" b="19122"/>
           <a:stretch xmlns:a="http://schemas.openxmlformats.org/drawingml/2006/main"/>
         </p:blipFill>
@@ -22701,7 +22821,7 @@
           <p:cNvPr id="13" name="">
             <a:extLst xmlns:a="http://schemas.openxmlformats.org/drawingml/2006/main">
               <a:ext uri="{FF2B5EF4-FFF2-40B4-BE49-F238E27FC236}">
-                <a16:creationId xmlns:a16="http://schemas.microsoft.com/office/drawing/2014/main" id="{7A379703-8781-4AEE-B707-1EAE656A663D}"/>
+                <a16:creationId xmlns:a16="http://schemas.microsoft.com/office/drawing/2014/main" id="{9E57FA6C-BAFD-4B30-8B6F-75E8FD66B4EC}"/>
               </a:ext>
             </a:extLst>
           </p:cNvPr>
@@ -22711,7 +22831,7 @@
           <p:nvPr/>
         </p:nvPicPr>
         <p:blipFill>
-          <a:blip xmlns:r="http://schemas.openxmlformats.org/officeDocument/2006/relationships" xmlns:a="http://schemas.openxmlformats.org/drawingml/2006/main" r:embed="R4291972244164d89"/>
+          <a:blip xmlns:r="http://schemas.openxmlformats.org/officeDocument/2006/relationships" xmlns:a="http://schemas.openxmlformats.org/drawingml/2006/main" r:embed="R086735794f8a413c"/>
           <a:srcRect xmlns:a="http://schemas.openxmlformats.org/drawingml/2006/main" l="0" t="3000" r="0" b="7500"/>
           <a:stretch xmlns:a="http://schemas.openxmlformats.org/drawingml/2006/main"/>
         </p:blipFill>
@@ -22896,7 +23016,7 @@
           <p:cNvPr id="15" name="">
             <a:extLst xmlns:a="http://schemas.openxmlformats.org/drawingml/2006/main">
               <a:ext uri="{FF2B5EF4-FFF2-40B4-BE49-F238E27FC236}">
-                <a16:creationId xmlns:a16="http://schemas.microsoft.com/office/drawing/2014/main" id="{D40D82FF-3B90-4BBF-9D7D-067CF1DC5C21}"/>
+                <a16:creationId xmlns:a16="http://schemas.microsoft.com/office/drawing/2014/main" id="{3D542BCF-EBC8-4D46-B35F-EA95F09AF342}"/>
               </a:ext>
             </a:extLst>
           </p:cNvPr>
@@ -22906,7 +23026,7 @@
           <p:nvPr/>
         </p:nvPicPr>
         <p:blipFill>
-          <a:blip xmlns:r="http://schemas.openxmlformats.org/officeDocument/2006/relationships" xmlns:a="http://schemas.openxmlformats.org/drawingml/2006/main" r:embed="Rdf43e836703c409f"/>
+          <a:blip xmlns:r="http://schemas.openxmlformats.org/officeDocument/2006/relationships" xmlns:a="http://schemas.openxmlformats.org/drawingml/2006/main" r:embed="R3420d878ece14c51"/>
           <a:srcRect xmlns:a="http://schemas.openxmlformats.org/drawingml/2006/main" l="37917" t="39063" r="37083" b="44188"/>
           <a:stretch xmlns:a="http://schemas.openxmlformats.org/drawingml/2006/main"/>
         </p:blipFill>
@@ -25987,7 +26107,7 @@
           <a:bodyPr xmlns:a="http://schemas.openxmlformats.org/drawingml/2006/main" lIns="0" tIns="0" rIns="0" bIns="0" anchor="t"/>
           <a:lstStyle xmlns:a="http://schemas.openxmlformats.org/drawingml/2006/main">
             <a:defPPr algn="l">
-              <a:defRPr sz="2100" b="0">
+              <a:defRPr sz="2025" b="0">
                 <a:solidFill>
                   <a:srgbClr val="263B34"/>
                 </a:solidFill>
@@ -26109,7 +26229,7 @@
               </a:defRPr>
             </a:pPr>
             <a:r>
-              <a:rPr sz="2100" b="0">
+              <a:rPr sz="2025" b="0">
                 <a:solidFill>
                   <a:srgbClr val="263B34"/>
                 </a:solidFill>
@@ -26117,7 +26237,7 @@
                 <a:ea typeface="Noto Sans"/>
                 <a:cs typeface="Noto Sans"/>
               </a:rPr>
-              <a:t>Report C1 P01-P05, con estratti e artefatti.</a:t>
+              <a:t>Report C1 P01-P05, estratti e artefatti.</a:t>
             </a:r>
           </a:p>
           <a:p xmlns:a="http://schemas.openxmlformats.org/drawingml/2006/main">
@@ -26133,7 +26253,7 @@
               </a:defRPr>
             </a:pPr>
             <a:r>
-              <a:rPr sz="2100" b="0">
+              <a:rPr sz="2025" b="0">
                 <a:solidFill>
                   <a:srgbClr val="263B34"/>
                 </a:solidFill>
@@ -26141,7 +26261,7 @@
                 <a:ea typeface="Noto Sans"/>
                 <a:cs typeface="Noto Sans"/>
               </a:rPr>
-              <a:t>Bisogni B01-B04 e loro risposte specifiche.</a:t>
+              <a:t>Diario P02 del 21–26 ottobre e analisi integrata.</a:t>
             </a:r>
           </a:p>
           <a:p xmlns:a="http://schemas.openxmlformats.org/drawingml/2006/main">
@@ -26157,7 +26277,7 @@
               </a:defRPr>
             </a:pPr>
             <a:r>
-              <a:rPr sz="2100" b="0">
+              <a:rPr sz="2025" b="0">
                 <a:solidFill>
                   <a:srgbClr val="263B34"/>
                 </a:solidFill>
@@ -26165,7 +26285,7 @@
                 <a:ea typeface="Noto Sans"/>
                 <a:cs typeface="Noto Sans"/>
               </a:rPr>
-              <a:t>Diario P02 e integrazione tematica: in attesa.</a:t>
+              <a:t>Bisogni B01-B04 con fonti specifiche.</a:t>
             </a:r>
           </a:p>
         </p:txBody>
@@ -26877,7 +26997,7 @@
                 <a:ea typeface="Noto Sans"/>
                 <a:cs typeface="Noto Sans"/>
               </a:rPr>
-              <a:t>Integrazioni ancora aperte: diario e analisi, contributi individuali e confronto conclusivo.</a:t>
+              <a:t>Restano il confronto conclusivo, le immagini aggiornate e il PDF definitivo.</a:t>
             </a:r>
           </a:p>
         </p:txBody>
@@ -27404,7 +27524,7 @@
                 <a:ea typeface="Noto Sans"/>
                 <a:cs typeface="Noto Sans"/>
               </a:rPr>
-              <a:t>P02-E06/E07/E08/E10/E12; P03-E04/E05/E07/E08 · Bozza C2</a:t>
+              <a:t>C1: P02/P03; diario P02-D01-E05/E07 e C01 · Bozza C2</a:t>
             </a:r>
           </a:p>
         </p:txBody>
@@ -33588,7 +33708,7 @@
                 <a:latin typeface="Noto Sans"/>
                 <a:ea typeface="Noto Sans"/>
                 <a:cs typeface="Noto Sans"/>
-                <a:hlinkClick xmlns:r="http://schemas.openxmlformats.org/officeDocument/2006/relationships" r:id="R5341bc50cf564450"/>
+                <a:hlinkClick xmlns:r="http://schemas.openxmlformats.org/officeDocument/2006/relationships" r:id="R3d535137b4bd425b"/>
               </a:rPr>
               <a:t>Descrizione dello sviluppatore nell’App Store</a:t>
             </a:r>
@@ -33921,7 +34041,7 @@
                 <a:latin typeface="Noto Sans"/>
                 <a:ea typeface="Noto Sans"/>
                 <a:cs typeface="Noto Sans"/>
-                <a:hlinkClick xmlns:r="http://schemas.openxmlformats.org/officeDocument/2006/relationships" r:id="R7ca992d197584c91"/>
+                <a:hlinkClick xmlns:r="http://schemas.openxmlformats.org/officeDocument/2006/relationships" r:id="R9bad70f6980543ad"/>
               </a:rPr>
               <a:t>Food+ e priorità degli alimenti</a:t>
             </a:r>
@@ -34254,7 +34374,7 @@
                 <a:latin typeface="Noto Sans"/>
                 <a:ea typeface="Noto Sans"/>
                 <a:cs typeface="Noto Sans"/>
-                <a:hlinkClick xmlns:r="http://schemas.openxmlformats.org/officeDocument/2006/relationships" r:id="R9be5be7b72734800"/>
+                <a:hlinkClick xmlns:r="http://schemas.openxmlformats.org/officeDocument/2006/relationships" r:id="R8386325ec7444059"/>
               </a:rPr>
               <a:t>Food List e gestione delle scorte</a:t>
             </a:r>
@@ -34587,7 +34707,7 @@
                 <a:latin typeface="Noto Sans"/>
                 <a:ea typeface="Noto Sans"/>
                 <a:cs typeface="Noto Sans"/>
-                <a:hlinkClick xmlns:r="http://schemas.openxmlformats.org/officeDocument/2006/relationships" r:id="Rb3ccd7b9f4d54575"/>
+                <a:hlinkClick xmlns:r="http://schemas.openxmlformats.org/officeDocument/2006/relationships" r:id="R48805af079ea412b"/>
               </a:rPr>
               <a:t>Meal Planner e ricette senza data</a:t>
             </a:r>
@@ -34920,7 +35040,7 @@
                 <a:latin typeface="Noto Sans"/>
                 <a:ea typeface="Noto Sans"/>
                 <a:cs typeface="Noto Sans"/>
-                <a:hlinkClick xmlns:r="http://schemas.openxmlformats.org/officeDocument/2006/relationships" r:id="R1a4406e9c1a0439d"/>
+                <a:hlinkClick xmlns:r="http://schemas.openxmlformats.org/officeDocument/2006/relationships" r:id="R181c7b0a88f6467e"/>
               </a:rPr>
               <a:t>Sostituzioni e conseguenze sulla preparazione</a:t>
             </a:r>
@@ -35253,7 +35373,7 @@
                 <a:latin typeface="Noto Sans"/>
                 <a:ea typeface="Noto Sans"/>
                 <a:cs typeface="Noto Sans"/>
-                <a:hlinkClick xmlns:r="http://schemas.openxmlformats.org/officeDocument/2006/relationships" r:id="Re59305d45dc74653"/>
+                <a:hlinkClick xmlns:r="http://schemas.openxmlformats.org/officeDocument/2006/relationships" r:id="Rc6f97319a7ac4b04"/>
               </a:rPr>
               <a:t>Pianificazione di ricette o ingredienti</a:t>
             </a:r>
@@ -35773,7 +35893,7 @@
                 <a:ea typeface="Noto Sans"/>
                 <a:cs typeface="Noto Sans"/>
               </a:rPr>
-              <a:t>Base: report C1 P01-P05 e feedback dei docenti · Bozza C2</a:t>
+              <a:t>Report C1 P01-P05; diario P02 del 21–26 ottobre · Bozza C2</a:t>
             </a:r>
           </a:p>
         </p:txBody>
@@ -36943,7 +37063,7 @@
                 <a:ea typeface="Noto Sans"/>
                 <a:cs typeface="Noto Sans"/>
               </a:rPr>
-              <a:t>Approfondimento con P02</a:t>
+              <a:t>Diario quotidiano con P02</a:t>
             </a:r>
           </a:p>
         </p:txBody>
@@ -37106,7 +37226,7 @@
                 <a:ea typeface="Noto Sans"/>
                 <a:cs typeface="Noto Sans"/>
               </a:rPr>
-              <a:t>Materiale in attesa</a:t>
+              <a:t>21–26 ottobre 2026 · sei giorni di appunti sul telefono</a:t>
             </a:r>
           </a:p>
         </p:txBody>
@@ -37269,7 +37389,7 @@
                 <a:ea typeface="Noto Sans"/>
                 <a:cs typeface="Noto Sans"/>
               </a:rPr>
-              <a:t>Scheda P02-C2-D01. Materiale in attesa · Bozza C2</a:t>
+              <a:t>P02-C2-D01; appunti e informazioni di raccolta M01/M02 · Bozza C2</a:t>
             </a:r>
           </a:p>
         </p:txBody>
@@ -37468,7 +37588,7 @@
           <a:bodyPr xmlns:a="http://schemas.openxmlformats.org/drawingml/2006/main" anchor="t"/>
           <a:lstStyle xmlns:a="http://schemas.openxmlformats.org/drawingml/2006/main">
             <a:defPPr>
-              <a:defRPr sz="2850" b="1">
+              <a:defRPr sz="2400" b="1">
                 <a:solidFill>
                   <a:srgbClr val="173A30"/>
                 </a:solidFill>
@@ -37587,7 +37707,7 @@
               </a:defRPr>
             </a:pPr>
             <a:r>
-              <a:rPr sz="2850" b="1">
+              <a:rPr sz="2400" b="1">
                 <a:solidFill>
                   <a:srgbClr val="173A30"/>
                 </a:solidFill>
@@ -37595,7 +37715,7 @@
                 <a:ea typeface="Noto Sans"/>
                 <a:cs typeface="Noto Sans"/>
               </a:rPr>
-              <a:t>Diario di circa 3–4 giorni su spesa e alimenti preparati</a:t>
+              <a:t>12 annotazioni sui pasti; spesa giorno per giorno in base alle esigenze.</a:t>
             </a:r>
           </a:p>
         </p:txBody>
@@ -37758,7 +37878,7 @@
                 <a:ea typeface="Noto Sans"/>
                 <a:cs typeface="Noto Sans"/>
               </a:rPr>
-              <a:t>Informazioni da registrare</a:t>
+              <a:t>Format e contesti</a:t>
             </a:r>
           </a:p>
         </p:txBody>
@@ -37794,7 +37914,7 @@
           <a:bodyPr xmlns:a="http://schemas.openxmlformats.org/drawingml/2006/main" anchor="t"/>
           <a:lstStyle xmlns:a="http://schemas.openxmlformats.org/drawingml/2006/main">
             <a:defPPr>
-              <a:defRPr sz="2175" b="0">
+              <a:defRPr sz="2025" b="0">
                 <a:solidFill>
                   <a:srgbClr val="263B34"/>
                 </a:solidFill>
@@ -37913,7 +38033,7 @@
               </a:defRPr>
             </a:pPr>
             <a:r>
-              <a:rPr sz="2175" b="0">
+              <a:rPr sz="2025" b="0">
                 <a:solidFill>
                   <a:srgbClr val="263B34"/>
                 </a:solidFill>
@@ -37921,7 +38041,7 @@
                 <a:ea typeface="Noto Sans"/>
                 <a:cs typeface="Noto Sans"/>
               </a:rPr>
-              <a:t>Periodo effettivo, contesto e modalità di raccolta. Distinguere annotazioni quotidiane da ricostruzione a posteriori.</a:t>
+              <a:t>Diario auto-compilato, raccolto in modo asincrono. Compaiono schiscetta, mensa universitaria e due pasti con un amico.</a:t>
             </a:r>
           </a:p>
         </p:txBody>
@@ -38084,7 +38204,7 @@
                 <a:ea typeface="Noto Sans"/>
                 <a:cs typeface="Noto Sans"/>
               </a:rPr>
-              <a:t>Pertinenza</a:t>
+              <a:t>Utente immediato</a:t>
             </a:r>
           </a:p>
         </p:txBody>
@@ -38120,7 +38240,7 @@
           <a:bodyPr xmlns:a="http://schemas.openxmlformats.org/drawingml/2006/main" anchor="t"/>
           <a:lstStyle xmlns:a="http://schemas.openxmlformats.org/drawingml/2006/main">
             <a:defPPr>
-              <a:defRPr sz="2175" b="0">
+              <a:defRPr sz="2025" b="0">
                 <a:solidFill>
                   <a:srgbClr val="263B34"/>
                 </a:solidFill>
@@ -38239,7 +38359,7 @@
               </a:defRPr>
             </a:pPr>
             <a:r>
-              <a:rPr sz="2175" b="0">
+              <a:rPr sz="2025" b="0">
                 <a:solidFill>
                   <a:srgbClr val="263B34"/>
                 </a:solidFill>
@@ -38247,7 +38367,7 @@
                 <a:ea typeface="Noto Sans"/>
                 <a:cs typeface="Noto Sans"/>
               </a:rPr>
-              <a:t>P02 ha già partecipato alla C1 e gestisce spesa e pasti. Il diario potrà descrivere decisioni e cambiamenti nella sua routine.</a:t>
+              <a:t>P02 gestisce spesa e pasti propri e aveva partecipato alla C1. Il diario approfondisce routine e occasioni reali di consumo.</a:t>
             </a:r>
           </a:p>
         </p:txBody>
@@ -38410,7 +38530,7 @@
                 <a:ea typeface="Noto Sans"/>
                 <a:cs typeface="Noto Sans"/>
               </a:rPr>
-              <a:t>Al momento non disponiamo di nuove osservazioni con utenti.</a:t>
+              <a:t>Quantità, tempi e acquisti per prodotto non sono annotati.</a:t>
             </a:r>
           </a:p>
         </p:txBody>
@@ -38602,7 +38722,7 @@
                 <a:ea typeface="Noto Sans"/>
                 <a:cs typeface="Noto Sans"/>
               </a:rPr>
-              <a:t>Episodi del diario</a:t>
+              <a:t>Un pasto rinviato al giorno dopo</a:t>
             </a:r>
           </a:p>
         </p:txBody>
@@ -38765,7 +38885,7 @@
                 <a:ea typeface="Noto Sans"/>
                 <a:cs typeface="Noto Sans"/>
               </a:rPr>
-              <a:t>Da compilare soltanto dopo aver ricevuto il materiale</a:t>
+              <a:t>Bowl prevista venerdì 23, consumata sabato 24</a:t>
             </a:r>
           </a:p>
         </p:txBody>
@@ -38928,7 +39048,7 @@
                 <a:ea typeface="Noto Sans"/>
                 <a:cs typeface="Noto Sans"/>
               </a:rPr>
-              <a:t>Diario P02. Episodi da integrare · Bozza C2</a:t>
+              <a:t>P02-D01-E05/E07 e chiarimento C01 · Bozza C2</a:t>
             </a:r>
           </a:p>
         </p:txBody>
@@ -39113,7 +39233,7 @@
         <p:spPr>
           <a:xfrm xmlns:a="http://schemas.openxmlformats.org/drawingml/2006/main">
             <a:off x="685800" y="2238375"/>
-            <a:ext cx="10820400" cy="619125"/>
+            <a:ext cx="10820400" cy="904875"/>
           </a:xfrm>
           <a:prstGeom xmlns:a="http://schemas.openxmlformats.org/drawingml/2006/main" prst="rect">
             <a:avLst/>
@@ -39127,7 +39247,7 @@
           <a:bodyPr xmlns:a="http://schemas.openxmlformats.org/drawingml/2006/main" anchor="t"/>
           <a:lstStyle xmlns:a="http://schemas.openxmlformats.org/drawingml/2006/main">
             <a:defPPr>
-              <a:defRPr sz="2850" b="1">
+              <a:defRPr sz="2400" b="1">
                 <a:solidFill>
                   <a:srgbClr val="173A30"/>
                 </a:solidFill>
@@ -39246,7 +39366,7 @@
               </a:defRPr>
             </a:pPr>
             <a:r>
-              <a:rPr sz="2850" b="1">
+              <a:rPr sz="2400" b="1">
                 <a:solidFill>
                   <a:srgbClr val="173A30"/>
                 </a:solidFill>
@@ -39254,7 +39374,7 @@
                 <a:ea typeface="Noto Sans"/>
                 <a:cs typeface="Noto Sans"/>
               </a:rPr>
-              <a:t>Estratti e occasioni reali di consumo</a:t>
+              <a:t>«di nuovo la bowl di pollo, perché era slittata da venerdì»</a:t>
             </a:r>
           </a:p>
         </p:txBody>
@@ -39275,8 +39395,8 @@
         </p:nvSpPr>
         <p:spPr>
           <a:xfrm xmlns:a="http://schemas.openxmlformats.org/drawingml/2006/main">
-            <a:off x="685800" y="3143250"/>
-            <a:ext cx="10382250" cy="1143000"/>
+            <a:off x="685800" y="3286125"/>
+            <a:ext cx="10382250" cy="1190625"/>
           </a:xfrm>
           <a:prstGeom xmlns:a="http://schemas.openxmlformats.org/drawingml/2006/main" prst="rect">
             <a:avLst/>
@@ -39290,7 +39410,7 @@
           <a:bodyPr xmlns:a="http://schemas.openxmlformats.org/drawingml/2006/main" anchor="t"/>
           <a:lstStyle xmlns:a="http://schemas.openxmlformats.org/drawingml/2006/main">
             <a:defPPr>
-              <a:defRPr sz="2400" b="0">
+              <a:defRPr sz="2100" b="0">
                 <a:solidFill>
                   <a:srgbClr val="263B34"/>
                 </a:solidFill>
@@ -39409,7 +39529,7 @@
               </a:defRPr>
             </a:pPr>
             <a:r>
-              <a:rPr sz="2400" b="0">
+              <a:rPr sz="2100" b="0">
                 <a:solidFill>
                   <a:srgbClr val="263B34"/>
                 </a:solidFill>
@@ -39417,7 +39537,7 @@
                 <a:ea typeface="Noto Sans"/>
                 <a:cs typeface="Noto Sans"/>
               </a:rPr>
-              <a:t>Per ogni episodio: che cosa era disponibile, che cosa P02 aveva previsto e che cosa ha preparato o acquistato.</a:t>
+              <a:t>Il chiarimento distingue la preparazione prevista venerdì dal consumo di sabato. Il motivo del rinvio e la cena effettiva di venerdì non sono specificati.</a:t>
             </a:r>
           </a:p>
         </p:txBody>
@@ -39453,7 +39573,7 @@
           <a:bodyPr xmlns:a="http://schemas.openxmlformats.org/drawingml/2006/main" anchor="t"/>
           <a:lstStyle xmlns:a="http://schemas.openxmlformats.org/drawingml/2006/main">
             <a:defPPr>
-              <a:defRPr sz="2250" b="0">
+              <a:defRPr sz="2100" b="0">
                 <a:solidFill>
                   <a:srgbClr val="56645D"/>
                 </a:solidFill>
@@ -39572,7 +39692,7 @@
               </a:defRPr>
             </a:pPr>
             <a:r>
-              <a:rPr sz="2250" b="0">
+              <a:rPr sz="2100" b="0">
                 <a:solidFill>
                   <a:srgbClr val="56645D"/>
                 </a:solidFill>
@@ -39580,7 +39700,7 @@
                 <a:ea typeface="Noto Sans"/>
                 <a:cs typeface="Noto Sans"/>
               </a:rPr>
-              <a:t>Conservare anche le strategie che funzionano e gli episodi che contraddicono le ipotesi iniziali.</a:t>
+              <a:t>L’adattamento riesce già nella routine. Il nuovo episodio rende concreta B03, senza descrivere una difficoltà irrisolta.</a:t>
             </a:r>
           </a:p>
         </p:txBody>
@@ -39935,7 +40055,7 @@
                 <a:ea typeface="Noto Sans"/>
                 <a:cs typeface="Noto Sans"/>
               </a:rPr>
-              <a:t>Schema di analisi predisposto. Gli esiti del diario sono ancora da ricavare.</a:t>
+              <a:t>Il diario approfondisce il rinvio e le occasioni di consumo</a:t>
             </a:r>
           </a:p>
         </p:txBody>
@@ -40098,7 +40218,7 @@
                 <a:ea typeface="Noto Sans"/>
                 <a:cs typeface="Noto Sans"/>
               </a:rPr>
-              <a:t>Report C1 e schema di integrazione tematica · Bozza C2</a:t>
+              <a:t>Analisi C1–C2: P02-D01 e report C1 P01-P05 · Bozza C2</a:t>
             </a:r>
           </a:p>
         </p:txBody>
@@ -40271,7 +40391,7 @@
           <p:cNvPr id="6" name="">
             <a:extLst xmlns:a="http://schemas.openxmlformats.org/drawingml/2006/main">
               <a:ext uri="{FF2B5EF4-FFF2-40B4-BE49-F238E27FC236}">
-                <a16:creationId xmlns:a16="http://schemas.microsoft.com/office/drawing/2014/main" id="{E362CA52-B07A-4A3A-83EC-40BE4E7E0AA0}"/>
+                <a16:creationId xmlns:a16="http://schemas.microsoft.com/office/drawing/2014/main" id="{97219434-23F3-4E56-8E2F-1113A60607EE}"/>
               </a:ext>
             </a:extLst>
           </p:cNvPr>
@@ -40287,9 +40407,9 @@
             <a:tbl>
               <a:tblPr/>
               <a:tblGrid>
-                <a:gridCol w="2476500"/>
-                <a:gridCol w="5953125"/>
-                <a:gridCol w="2390775"/>
+                <a:gridCol w="2095500"/>
+                <a:gridCol w="4286250"/>
+                <a:gridCol w="4438650"/>
               </a:tblGrid>
               <a:tr h="495300">
                 <a:tc>
@@ -40298,7 +40418,7 @@
                     <a:lstStyle/>
                     <a:p>
                       <a:r>
-                        <a:rPr sz="1950" b="1">
+                        <a:rPr sz="1800" b="1">
                           <a:solidFill>
                             <a:srgbClr val="FFFFFF"/>
                           </a:solidFill>
@@ -40307,7 +40427,7 @@
                       </a:r>
                     </a:p>
                   </a:txBody>
-                  <a:tcPr marL="114300" marR="114300" marT="76200" marB="76200" anchor="t">
+                  <a:tcPr marL="76200" marR="76200" marT="76200" marB="76200" anchor="t">
                     <a:lnL w="9525">
                       <a:solidFill>
                         <a:srgbClr val="D7DFD6"/>
@@ -40343,16 +40463,16 @@
                     <a:lstStyle/>
                     <a:p>
                       <a:r>
-                        <a:rPr sz="1950" b="1">
+                        <a:rPr sz="1800" b="1">
                           <a:solidFill>
                             <a:srgbClr val="FFFFFF"/>
                           </a:solidFill>
                         </a:rPr>
-                        <a:t>Che cosa cercare nel diario</a:t>
+                        <a:t>Diario P02</a:t>
                       </a:r>
                     </a:p>
                   </a:txBody>
-                  <a:tcPr marL="114300" marR="114300" marT="76200" marB="76200" anchor="t">
+                  <a:tcPr marL="76200" marR="76200" marT="76200" marB="76200" anchor="t">
                     <a:lnR w="9525">
                       <a:solidFill>
                         <a:srgbClr val="D7DFD6"/>
@@ -40382,16 +40502,16 @@
                     <a:lstStyle/>
                     <a:p>
                       <a:r>
-                        <a:rPr sz="1950" b="1">
+                        <a:rPr sz="1800" b="1">
                           <a:solidFill>
                             <a:srgbClr val="FFFFFF"/>
                           </a:solidFill>
                         </a:rPr>
-                        <a:t>Esito</a:t>
+                        <a:t>Che cosa aggiunge</a:t>
                       </a:r>
                     </a:p>
                   </a:txBody>
-                  <a:tcPr marL="114300" marR="114300" marT="76200" marB="76200" anchor="t">
+                  <a:tcPr marL="76200" marR="76200" marT="76200" marB="76200" anchor="t">
                     <a:lnR w="9525">
                       <a:solidFill>
                         <a:srgbClr val="D7DFD6"/>
@@ -40416,23 +40536,23 @@
                   </a:tcPr>
                 </a:tc>
               </a:tr>
-              <a:tr h="881063">
+              <a:tr h="1047750">
                 <a:tc>
                   <a:txBody>
                     <a:bodyPr/>
                     <a:lstStyle/>
                     <a:p>
                       <a:r>
-                        <a:rPr sz="1950">
+                        <a:rPr sz="1800">
                           <a:solidFill>
                             <a:srgbClr val="263B34"/>
                           </a:solidFill>
                         </a:rPr>
-                        <a:t>Alimenti disponibili</a:t>
+                        <a:t>Occasioni dei pasti</a:t>
                       </a:r>
                     </a:p>
                   </a:txBody>
-                  <a:tcPr marL="133350" marR="133350" marT="114300" marB="114300" anchor="t">
+                  <a:tcPr marL="76200" marR="76200" marT="76200" marB="76200" anchor="t">
                     <a:lnL w="9525">
                       <a:solidFill>
                         <a:srgbClr val="D7DFD6"/>
@@ -40462,16 +40582,16 @@
                     <a:lstStyle/>
                     <a:p>
                       <a:r>
-                        <a:rPr sz="1950">
+                        <a:rPr sz="1800">
                           <a:solidFill>
                             <a:srgbClr val="263B34"/>
                           </a:solidFill>
                         </a:rPr>
-                        <a:t>Prodotti riconosciuti, trascurati o usati prima</a:t>
+                        <a:t>Schiscetta il 23, mensa il 26; cous cous e zucchine ricorrono in pasti diversi.</a:t>
                       </a:r>
                     </a:p>
                   </a:txBody>
-                  <a:tcPr marL="133350" marR="133350" marT="114300" marB="114300" anchor="t">
+                  <a:tcPr marL="76200" marR="76200" marT="76200" marB="76200" anchor="t">
                     <a:lnR w="9525">
                       <a:solidFill>
                         <a:srgbClr val="D7DFD6"/>
@@ -40495,16 +40615,16 @@
                     <a:lstStyle/>
                     <a:p>
                       <a:r>
-                        <a:rPr sz="1950">
+                        <a:rPr sz="1800">
                           <a:solidFill>
                             <a:srgbClr val="263B34"/>
                           </a:solidFill>
                         </a:rPr>
-                        <a:t>Da analizzare</a:t>
+                        <a:t>B02/C07: contesti concreti. Il riuso della stessa confezione non è accertato.</a:t>
                       </a:r>
                     </a:p>
                   </a:txBody>
-                  <a:tcPr marL="133350" marR="133350" marT="114300" marB="114300" anchor="t">
+                  <a:tcPr marL="76200" marR="76200" marT="76200" marB="76200" anchor="t">
                     <a:lnR w="9525">
                       <a:solidFill>
                         <a:srgbClr val="D7DFD6"/>
@@ -40523,23 +40643,23 @@
                   </a:tcPr>
                 </a:tc>
               </a:tr>
-              <a:tr h="881063">
+              <a:tr h="1047750">
                 <a:tc>
                   <a:txBody>
                     <a:bodyPr/>
                     <a:lstStyle/>
                     <a:p>
                       <a:r>
-                        <a:rPr sz="1950">
+                        <a:rPr sz="1800">
                           <a:solidFill>
                             <a:srgbClr val="263B34"/>
                           </a:solidFill>
                         </a:rPr>
-                        <a:t>Pasto praticabile</a:t>
+                        <a:t>Adattamento</a:t>
                       </a:r>
                     </a:p>
                   </a:txBody>
-                  <a:tcPr marL="133350" marR="133350" marT="114300" marB="114300" anchor="t">
+                  <a:tcPr marL="76200" marR="76200" marT="76200" marB="76200" anchor="t">
                     <a:lnL w="9525">
                       <a:solidFill>
                         <a:srgbClr val="D7DFD6"/>
@@ -40569,16 +40689,16 @@
                     <a:lstStyle/>
                     <a:p>
                       <a:r>
-                        <a:rPr sz="1950">
+                        <a:rPr sz="1800">
                           <a:solidFill>
                             <a:srgbClr val="263B34"/>
                           </a:solidFill>
                         </a:rPr>
-                        <a:t>Tempo, impegno e preparazioni già familiari</a:t>
+                        <a:t>Bowl prevista venerdì e consumata sabato, dopo il rinvio.</a:t>
                       </a:r>
                     </a:p>
                   </a:txBody>
-                  <a:tcPr marL="133350" marR="133350" marT="114300" marB="114300" anchor="t">
+                  <a:tcPr marL="76200" marR="76200" marT="76200" marB="76200" anchor="t">
                     <a:lnR w="9525">
                       <a:solidFill>
                         <a:srgbClr val="D7DFD6"/>
@@ -40602,16 +40722,16 @@
                     <a:lstStyle/>
                     <a:p>
                       <a:r>
-                        <a:rPr sz="1950">
+                        <a:rPr sz="1800">
                           <a:solidFill>
                             <a:srgbClr val="263B34"/>
                           </a:solidFill>
                         </a:rPr>
-                        <a:t>Da analizzare</a:t>
+                        <a:t>B03: nuova occasione di consumo e strategia già riuscita.</a:t>
                       </a:r>
                     </a:p>
                   </a:txBody>
-                  <a:tcPr marL="133350" marR="133350" marT="114300" marB="114300" anchor="t">
+                  <a:tcPr marL="76200" marR="76200" marT="76200" marB="76200" anchor="t">
                     <a:lnR w="9525">
                       <a:solidFill>
                         <a:srgbClr val="D7DFD6"/>
@@ -40630,23 +40750,23 @@
                   </a:tcPr>
                 </a:tc>
               </a:tr>
-              <a:tr h="881063">
+              <a:tr h="1047750">
                 <a:tc>
                   <a:txBody>
                     <a:bodyPr/>
                     <a:lstStyle/>
                     <a:p>
                       <a:r>
-                        <a:rPr sz="1950">
+                        <a:rPr sz="1800">
                           <a:solidFill>
                             <a:srgbClr val="263B34"/>
                           </a:solidFill>
                         </a:rPr>
-                        <a:t>Cambiamenti e quantità</a:t>
+                        <a:t>Spesa e scorte</a:t>
                       </a:r>
                     </a:p>
                   </a:txBody>
-                  <a:tcPr marL="133350" marR="133350" marT="114300" marB="114300" anchor="t">
+                  <a:tcPr marL="76200" marR="76200" marT="76200" marB="76200" anchor="t">
                     <a:lnL w="9525">
                       <a:solidFill>
                         <a:srgbClr val="D7DFD6"/>
@@ -40676,16 +40796,16 @@
                     <a:lstStyle/>
                     <a:p>
                       <a:r>
-                        <a:rPr sz="1950">
+                        <a:rPr sz="1800">
                           <a:solidFill>
                             <a:srgbClr val="263B34"/>
                           </a:solidFill>
                         </a:rPr>
-                        <a:t>Rinvii, destinazioni successive, acquisti e consumo</a:t>
+                        <a:t>Acquisti giorno per giorno; quantità e inventario non annotati.</a:t>
                       </a:r>
                     </a:p>
                   </a:txBody>
-                  <a:tcPr marL="133350" marR="133350" marT="114300" marB="114300" anchor="t">
+                  <a:tcPr marL="76200" marR="76200" marT="76200" marB="76200" anchor="t">
                     <a:lnR w="9525">
                       <a:solidFill>
                         <a:srgbClr val="D7DFD6"/>
@@ -40709,16 +40829,16 @@
                     <a:lstStyle/>
                     <a:p>
                       <a:r>
-                        <a:rPr sz="1950">
+                        <a:rPr sz="1800">
                           <a:solidFill>
                             <a:srgbClr val="263B34"/>
                           </a:solidFill>
                         </a:rPr>
-                        <a:t>Da analizzare</a:t>
+                        <a:t>B01/B04 restano fondati sulla C1: nessuna nuova prova di spreco o eccesso.</a:t>
                       </a:r>
                     </a:p>
                   </a:txBody>
-                  <a:tcPr marL="133350" marR="133350" marT="114300" marB="114300" anchor="t">
+                  <a:tcPr marL="76200" marR="76200" marT="76200" marB="76200" anchor="t">
                     <a:lnR w="9525">
                       <a:solidFill>
                         <a:srgbClr val="D7DFD6"/>
@@ -40757,8 +40877,8 @@
         </p:nvSpPr>
         <p:spPr>
           <a:xfrm xmlns:a="http://schemas.openxmlformats.org/drawingml/2006/main">
-            <a:off x="685800" y="5819775"/>
-            <a:ext cx="10820400" cy="419100"/>
+            <a:off x="685800" y="5886450"/>
+            <a:ext cx="10820400" cy="333375"/>
           </a:xfrm>
           <a:prstGeom xmlns:a="http://schemas.openxmlformats.org/drawingml/2006/main" prst="rect">
             <a:avLst/>
@@ -40899,7 +41019,7 @@
                 <a:ea typeface="Noto Sans"/>
                 <a:cs typeface="Noto Sans"/>
               </a:rPr>
-              <a:t>Aggiornare bisogni e priorità in base ai riscontri, senza presupporre che confermino D3.</a:t>
+              <a:t>Rivediamo i prossimi pasti, conservando le strategie che funzionano già.</a:t>
             </a:r>
           </a:p>
         </p:txBody>
@@ -41602,7 +41722,7 @@
           <p:cNvPr id="6" name="">
             <a:extLst xmlns:a="http://schemas.openxmlformats.org/drawingml/2006/main">
               <a:ext uri="{FF2B5EF4-FFF2-40B4-BE49-F238E27FC236}">
-                <a16:creationId xmlns:a16="http://schemas.microsoft.com/office/drawing/2014/main" id="{996CA7DB-87E2-4310-8B2F-B0BAC393D85E}"/>
+                <a16:creationId xmlns:a16="http://schemas.microsoft.com/office/drawing/2014/main" id="{C1003E89-BEE8-4F37-8D0C-DC777CD89DD8}"/>
               </a:ext>
             </a:extLst>
           </p:cNvPr>
@@ -41612,7 +41732,7 @@
           <p:nvPr/>
         </p:nvPicPr>
         <p:blipFill>
-          <a:blip xmlns:r="http://schemas.openxmlformats.org/officeDocument/2006/relationships" xmlns:a="http://schemas.openxmlformats.org/drawingml/2006/main" r:embed="R9e985aa096834069"/>
+          <a:blip xmlns:r="http://schemas.openxmlformats.org/officeDocument/2006/relationships" xmlns:a="http://schemas.openxmlformats.org/drawingml/2006/main" r:embed="Re40e743a61cd4154"/>
           <a:stretch xmlns:a="http://schemas.openxmlformats.org/drawingml/2006/main"/>
         </p:blipFill>
         <p:spPr>
@@ -42157,7 +42277,7 @@
           <p:cNvPr id="4" name="">
             <a:extLst xmlns:a="http://schemas.openxmlformats.org/drawingml/2006/main">
               <a:ext uri="{FF2B5EF4-FFF2-40B4-BE49-F238E27FC236}">
-                <a16:creationId xmlns:a16="http://schemas.microsoft.com/office/drawing/2014/main" id="{713C9E0C-348F-4F6A-87B4-D75A465DA146}"/>
+                <a16:creationId xmlns:a16="http://schemas.microsoft.com/office/drawing/2014/main" id="{16E31954-7653-461E-8EA8-DAB48DA01C2E}"/>
               </a:ext>
             </a:extLst>
           </p:cNvPr>

</xml_diff>